<commit_message>
feat: ErrorCode 0~5 구현 및 LED3 오류 표시, DIP SW 네트워크 모드, LAN8720 지원, RFP 문서 업데이트
</commit_message>
<xml_diff>
--- a/doc/정리.pptx
+++ b/doc/정리.pptx
@@ -261,7 +261,7 @@
           <a:p>
             <a:fld id="{061AD99C-C82C-45BA-8D00-686C6DF5AB4F}" type="datetimeFigureOut">
               <a:rPr lang="ko-KR" altLang="en-US" smtClean="0"/>
-              <a:t>2026-06-14</a:t>
+              <a:t>2026-06-23</a:t>
             </a:fld>
             <a:endParaRPr lang="ko-KR" altLang="en-US"/>
           </a:p>
@@ -459,7 +459,7 @@
           <a:p>
             <a:fld id="{061AD99C-C82C-45BA-8D00-686C6DF5AB4F}" type="datetimeFigureOut">
               <a:rPr lang="ko-KR" altLang="en-US" smtClean="0"/>
-              <a:t>2026-06-14</a:t>
+              <a:t>2026-06-23</a:t>
             </a:fld>
             <a:endParaRPr lang="ko-KR" altLang="en-US"/>
           </a:p>
@@ -667,7 +667,7 @@
           <a:p>
             <a:fld id="{061AD99C-C82C-45BA-8D00-686C6DF5AB4F}" type="datetimeFigureOut">
               <a:rPr lang="ko-KR" altLang="en-US" smtClean="0"/>
-              <a:t>2026-06-14</a:t>
+              <a:t>2026-06-23</a:t>
             </a:fld>
             <a:endParaRPr lang="ko-KR" altLang="en-US"/>
           </a:p>
@@ -865,7 +865,7 @@
           <a:p>
             <a:fld id="{061AD99C-C82C-45BA-8D00-686C6DF5AB4F}" type="datetimeFigureOut">
               <a:rPr lang="ko-KR" altLang="en-US" smtClean="0"/>
-              <a:t>2026-06-14</a:t>
+              <a:t>2026-06-23</a:t>
             </a:fld>
             <a:endParaRPr lang="ko-KR" altLang="en-US"/>
           </a:p>
@@ -1140,7 +1140,7 @@
           <a:p>
             <a:fld id="{061AD99C-C82C-45BA-8D00-686C6DF5AB4F}" type="datetimeFigureOut">
               <a:rPr lang="ko-KR" altLang="en-US" smtClean="0"/>
-              <a:t>2026-06-14</a:t>
+              <a:t>2026-06-23</a:t>
             </a:fld>
             <a:endParaRPr lang="ko-KR" altLang="en-US"/>
           </a:p>
@@ -1405,7 +1405,7 @@
           <a:p>
             <a:fld id="{061AD99C-C82C-45BA-8D00-686C6DF5AB4F}" type="datetimeFigureOut">
               <a:rPr lang="ko-KR" altLang="en-US" smtClean="0"/>
-              <a:t>2026-06-14</a:t>
+              <a:t>2026-06-23</a:t>
             </a:fld>
             <a:endParaRPr lang="ko-KR" altLang="en-US"/>
           </a:p>
@@ -1817,7 +1817,7 @@
           <a:p>
             <a:fld id="{061AD99C-C82C-45BA-8D00-686C6DF5AB4F}" type="datetimeFigureOut">
               <a:rPr lang="ko-KR" altLang="en-US" smtClean="0"/>
-              <a:t>2026-06-14</a:t>
+              <a:t>2026-06-23</a:t>
             </a:fld>
             <a:endParaRPr lang="ko-KR" altLang="en-US"/>
           </a:p>
@@ -1958,7 +1958,7 @@
           <a:p>
             <a:fld id="{061AD99C-C82C-45BA-8D00-686C6DF5AB4F}" type="datetimeFigureOut">
               <a:rPr lang="ko-KR" altLang="en-US" smtClean="0"/>
-              <a:t>2026-06-14</a:t>
+              <a:t>2026-06-23</a:t>
             </a:fld>
             <a:endParaRPr lang="ko-KR" altLang="en-US"/>
           </a:p>
@@ -2071,7 +2071,7 @@
           <a:p>
             <a:fld id="{061AD99C-C82C-45BA-8D00-686C6DF5AB4F}" type="datetimeFigureOut">
               <a:rPr lang="ko-KR" altLang="en-US" smtClean="0"/>
-              <a:t>2026-06-14</a:t>
+              <a:t>2026-06-23</a:t>
             </a:fld>
             <a:endParaRPr lang="ko-KR" altLang="en-US"/>
           </a:p>
@@ -2382,7 +2382,7 @@
           <a:p>
             <a:fld id="{061AD99C-C82C-45BA-8D00-686C6DF5AB4F}" type="datetimeFigureOut">
               <a:rPr lang="ko-KR" altLang="en-US" smtClean="0"/>
-              <a:t>2026-06-14</a:t>
+              <a:t>2026-06-23</a:t>
             </a:fld>
             <a:endParaRPr lang="ko-KR" altLang="en-US"/>
           </a:p>
@@ -2670,7 +2670,7 @@
           <a:p>
             <a:fld id="{061AD99C-C82C-45BA-8D00-686C6DF5AB4F}" type="datetimeFigureOut">
               <a:rPr lang="ko-KR" altLang="en-US" smtClean="0"/>
-              <a:t>2026-06-14</a:t>
+              <a:t>2026-06-23</a:t>
             </a:fld>
             <a:endParaRPr lang="ko-KR" altLang="en-US"/>
           </a:p>
@@ -2911,7 +2911,7 @@
           <a:p>
             <a:fld id="{061AD99C-C82C-45BA-8D00-686C6DF5AB4F}" type="datetimeFigureOut">
               <a:rPr lang="ko-KR" altLang="en-US" smtClean="0"/>
-              <a:t>2026-06-14</a:t>
+              <a:t>2026-06-23</a:t>
             </a:fld>
             <a:endParaRPr lang="ko-KR" altLang="en-US"/>
           </a:p>
@@ -5019,6 +5019,247 @@
           <a:chExt cx="0" cy="0"/>
         </a:xfrm>
       </p:grpSpPr>
+      <p:pic>
+        <p:nvPicPr>
+          <p:cNvPr id="3" name="그림 2">
+            <a:extLst>
+              <a:ext uri="{FF2B5EF4-FFF2-40B4-BE49-F238E27FC236}">
+                <a16:creationId xmlns:a16="http://schemas.microsoft.com/office/drawing/2014/main" id="{12F46438-6379-1AA9-0A54-393CD601B807}"/>
+              </a:ext>
+            </a:extLst>
+          </p:cNvPr>
+          <p:cNvPicPr>
+            <a:picLocks noChangeAspect="1"/>
+          </p:cNvPicPr>
+          <p:nvPr/>
+        </p:nvPicPr>
+        <p:blipFill>
+          <a:blip r:embed="rId2"/>
+          <a:stretch>
+            <a:fillRect/>
+          </a:stretch>
+        </p:blipFill>
+        <p:spPr>
+          <a:xfrm>
+            <a:off x="375811" y="113938"/>
+            <a:ext cx="4031366" cy="1705337"/>
+          </a:xfrm>
+          <a:prstGeom prst="rect">
+            <a:avLst/>
+          </a:prstGeom>
+        </p:spPr>
+      </p:pic>
+      <p:pic>
+        <p:nvPicPr>
+          <p:cNvPr id="5" name="그림 4">
+            <a:extLst>
+              <a:ext uri="{FF2B5EF4-FFF2-40B4-BE49-F238E27FC236}">
+                <a16:creationId xmlns:a16="http://schemas.microsoft.com/office/drawing/2014/main" id="{7D3F6372-C49E-4DB5-6F06-2105428B0AB6}"/>
+              </a:ext>
+            </a:extLst>
+          </p:cNvPr>
+          <p:cNvPicPr>
+            <a:picLocks noChangeAspect="1"/>
+          </p:cNvPicPr>
+          <p:nvPr/>
+        </p:nvPicPr>
+        <p:blipFill>
+          <a:blip r:embed="rId3"/>
+          <a:stretch>
+            <a:fillRect/>
+          </a:stretch>
+        </p:blipFill>
+        <p:spPr>
+          <a:xfrm>
+            <a:off x="6875443" y="113938"/>
+            <a:ext cx="4118943" cy="3176913"/>
+          </a:xfrm>
+          <a:prstGeom prst="rect">
+            <a:avLst/>
+          </a:prstGeom>
+        </p:spPr>
+      </p:pic>
+      <p:pic>
+        <p:nvPicPr>
+          <p:cNvPr id="7" name="그림 6">
+            <a:extLst>
+              <a:ext uri="{FF2B5EF4-FFF2-40B4-BE49-F238E27FC236}">
+                <a16:creationId xmlns:a16="http://schemas.microsoft.com/office/drawing/2014/main" id="{372BBB49-EEAB-9A77-FF30-6E7A2F6E67F8}"/>
+              </a:ext>
+            </a:extLst>
+          </p:cNvPr>
+          <p:cNvPicPr>
+            <a:picLocks noChangeAspect="1"/>
+          </p:cNvPicPr>
+          <p:nvPr/>
+        </p:nvPicPr>
+        <p:blipFill>
+          <a:blip r:embed="rId4"/>
+          <a:stretch>
+            <a:fillRect/>
+          </a:stretch>
+        </p:blipFill>
+        <p:spPr>
+          <a:xfrm>
+            <a:off x="6951643" y="3567150"/>
+            <a:ext cx="3704075" cy="2895600"/>
+          </a:xfrm>
+          <a:prstGeom prst="rect">
+            <a:avLst/>
+          </a:prstGeom>
+        </p:spPr>
+      </p:pic>
+      <p:sp>
+        <p:nvSpPr>
+          <p:cNvPr id="8" name="TextBox 7">
+            <a:extLst>
+              <a:ext uri="{FF2B5EF4-FFF2-40B4-BE49-F238E27FC236}">
+                <a16:creationId xmlns:a16="http://schemas.microsoft.com/office/drawing/2014/main" id="{BDC7E71B-6386-245C-DBBA-ED724394A207}"/>
+              </a:ext>
+            </a:extLst>
+          </p:cNvPr>
+          <p:cNvSpPr txBox="1"/>
+          <p:nvPr/>
+        </p:nvSpPr>
+        <p:spPr>
+          <a:xfrm>
+            <a:off x="483914" y="3895725"/>
+            <a:ext cx="3962400" cy="646331"/>
+          </a:xfrm>
+          <a:prstGeom prst="rect">
+            <a:avLst/>
+          </a:prstGeom>
+          <a:noFill/>
+        </p:spPr>
+        <p:txBody>
+          <a:bodyPr wrap="square" rtlCol="0">
+            <a:spAutoFit/>
+          </a:bodyPr>
+          <a:lstStyle/>
+          <a:p>
+            <a:r>
+              <a:rPr lang="en-US" altLang="ko-KR"/>
+              <a:t> TRDR</a:t>
+            </a:r>
+          </a:p>
+          <a:p>
+            <a:r>
+              <a:rPr lang="en-US" altLang="ko-KR"/>
+              <a:t>dosadosa</a:t>
+            </a:r>
+            <a:endParaRPr lang="ko-KR" altLang="en-US"/>
+          </a:p>
+        </p:txBody>
+      </p:sp>
+      <p:sp>
+        <p:nvSpPr>
+          <p:cNvPr id="9" name="TextBox 8">
+            <a:extLst>
+              <a:ext uri="{FF2B5EF4-FFF2-40B4-BE49-F238E27FC236}">
+                <a16:creationId xmlns:a16="http://schemas.microsoft.com/office/drawing/2014/main" id="{D5C75B70-EF73-CD2B-AC44-DB8F05DFD75B}"/>
+              </a:ext>
+            </a:extLst>
+          </p:cNvPr>
+          <p:cNvSpPr txBox="1"/>
+          <p:nvPr/>
+        </p:nvSpPr>
+        <p:spPr>
+          <a:xfrm>
+            <a:off x="409575" y="2199322"/>
+            <a:ext cx="5362575" cy="1477328"/>
+          </a:xfrm>
+          <a:prstGeom prst="rect">
+            <a:avLst/>
+          </a:prstGeom>
+          <a:noFill/>
+        </p:spPr>
+        <p:txBody>
+          <a:bodyPr wrap="square" rtlCol="0">
+            <a:spAutoFit/>
+          </a:bodyPr>
+          <a:lstStyle/>
+          <a:p>
+            <a:r>
+              <a:rPr lang="en-US" altLang="ko-KR"/>
+              <a:t>TPLINK</a:t>
+            </a:r>
+            <a:r>
+              <a:rPr lang="ko-KR" altLang="en-US"/>
+              <a:t> </a:t>
+            </a:r>
+            <a:endParaRPr lang="en-US" altLang="ko-KR"/>
+          </a:p>
+          <a:p>
+            <a:pPr marL="342900" indent="-342900">
+              <a:buAutoNum type="arabicPeriod"/>
+            </a:pPr>
+            <a:r>
+              <a:rPr lang="ko-KR" altLang="en-US"/>
+              <a:t>처음 접속</a:t>
+            </a:r>
+            <a:r>
+              <a:rPr lang="en-US" altLang="ko-KR"/>
+              <a:t>: </a:t>
+            </a:r>
+            <a:r>
+              <a:rPr lang="en-US" altLang="ko-KR">
+                <a:hlinkClick r:id="rId5"/>
+              </a:rPr>
+              <a:t>http://tplinkwifi.net</a:t>
+            </a:r>
+            <a:endParaRPr lang="en-US" altLang="ko-KR"/>
+          </a:p>
+          <a:p>
+            <a:pPr marL="342900" indent="-342900">
+              <a:buAutoNum type="arabicPeriod" startAt="2"/>
+            </a:pPr>
+            <a:r>
+              <a:rPr lang="ko-KR" altLang="en-US"/>
+              <a:t>패스워드입력</a:t>
+            </a:r>
+            <a:r>
+              <a:rPr lang="en-US" altLang="ko-KR"/>
+              <a:t>: DOsa8096 </a:t>
+            </a:r>
+          </a:p>
+          <a:p>
+            <a:pPr marL="342900" indent="-342900">
+              <a:buAutoNum type="arabicPeriod" startAt="2"/>
+            </a:pPr>
+            <a:r>
+              <a:rPr lang="ko-KR" altLang="en-US"/>
+              <a:t>공유기모드 설정 </a:t>
+            </a:r>
+            <a:endParaRPr lang="en-US" altLang="ko-KR"/>
+          </a:p>
+          <a:p>
+            <a:pPr marL="342900" indent="-342900">
+              <a:buAutoNum type="arabicPeriod" startAt="2"/>
+            </a:pPr>
+            <a:r>
+              <a:rPr lang="en-US" altLang="ko-KR"/>
+              <a:t>SSID</a:t>
+            </a:r>
+            <a:r>
+              <a:rPr lang="ko-KR" altLang="en-US"/>
+              <a:t> 설정 </a:t>
+            </a:r>
+            <a:r>
+              <a:rPr lang="en-US" altLang="ko-KR">
+                <a:sym typeface="Wingdings" panose="05000000000000000000" pitchFamily="2" charset="2"/>
+              </a:rPr>
+              <a:t> </a:t>
+            </a:r>
+            <a:r>
+              <a:rPr lang="ko-KR" altLang="en-US">
+                <a:sym typeface="Wingdings" panose="05000000000000000000" pitchFamily="2" charset="2"/>
+              </a:rPr>
+              <a:t>재부팅 </a:t>
+            </a:r>
+            <a:endParaRPr lang="ko-KR" altLang="en-US"/>
+          </a:p>
+        </p:txBody>
+      </p:sp>
     </p:spTree>
     <p:extLst>
       <p:ext uri="{BB962C8B-B14F-4D97-AF65-F5344CB8AC3E}">

</xml_diff>